<commit_message>
Actualizar entregables con acceso HTTPS
</commit_message>
<xml_diff>
--- a/entregables/Presentacion_Savia_IoT_Practica_1_Azure_para_compartir.pptx
+++ b/entregables/Presentacion_Savia_IoT_Practica_1_Azure_para_compartir.pptx
@@ -6128,6 +6128,10 @@
             <a:prstDash val="solid"/>
           </a:ln>
         </p:spPr>
+        <p:txBody xmlns:a="http://schemas.openxmlformats.org/drawingml/2006/main">
+          <a:bodyPr/>
+          <a:p/>
+        </p:txBody>
       </p:sp>
       <p:sp>
         <p:nvSpPr>
@@ -6334,6 +6338,10 @@
             <a:prstDash val="solid"/>
           </a:ln>
         </p:spPr>
+        <p:txBody xmlns:a="http://schemas.openxmlformats.org/drawingml/2006/main">
+          <a:bodyPr/>
+          <a:p/>
+        </p:txBody>
       </p:sp>
       <p:sp>
         <p:nvSpPr>
@@ -6495,7 +6503,7 @@
                   <a:srgbClr val="52645A"/>
                 </a:solidFill>
               </a:rPr>
-              <a:t>NSG: HTTP + SSH limitado</a:t>
+              <a:t>NSG: HTTPS + SSH limitado</a:t>
             </a:r>
           </a:p>
         </p:txBody>
@@ -6591,6 +6599,10 @@
             <a:prstDash val="solid"/>
           </a:ln>
         </p:spPr>
+        <p:txBody xmlns:a="http://schemas.openxmlformats.org/drawingml/2006/main">
+          <a:bodyPr/>
+          <a:p/>
+        </p:txBody>
       </p:sp>
       <p:sp>
         <p:nvSpPr>
@@ -6848,8 +6860,9 @@
                 <a:solidFill>
                   <a:srgbClr val="18533F"/>
                 </a:solidFill>
+                <a:hlinkClick xmlns:ns0="http://schemas.openxmlformats.org/officeDocument/2006/relationships" ns0:id="rId3"/>
               </a:rPr>
-              <a:t>IP pública: 23.101.172.173 · /health activo · PostgreSQL privado</a:t>
+              <a:t>Acceso HTTPS: 23-101-172-173.sslip.io · PostgreSQL privado</a:t>
             </a:r>
           </a:p>
         </p:txBody>

</xml_diff>